<commit_message>
fix(deck): per-study forcing labels (NLDAS runs no longer say Qian)
The results-slide definitions footnote and appendix subtitle hard-coded
CLM_QIAN for every study. forcing_label() now resolves per run: forcing.txt
marker (written by build_cases going forward, backfilled for existing runs)
-> surviving DATM stream detection -> dirname heuristic. Verified: only the
four Qian studies mention Qian; the two NLDAS studies say NLDAS-2.

Co-Authored-By: Claude Opus 4.8 <noreply@anthropic.com>
</commit_message>
<xml_diff>
--- a/docs/slides/story_20260705.pptx
+++ b/docs/slides/story_20260705.pptx
@@ -4151,7 +4151,7 @@
                   <a:srgbClr val="475569"/>
                 </a:solidFill>
               </a:rPr>
-              <a:t>Definitions — recharge = ELM QCHARGE (flux from the soil column to the water table); runoff = QOVER (surface runoff); recharge fraction = QCHARGE/(QCHARGE+QOVER); WTD = ZWT (the column's own water-table depth); forcing = CLM_QIAN (Qian 2006, T62 ≈ 1.9°) precip at the column.</a:t>
+              <a:t>Definitions — recharge = ELM QCHARGE (flux from the soil column to the water table); runoff = QOVER (surface runoff); recharge fraction = QCHARGE/(QCHARGE+QOVER); WTD = ZWT (the column's own water-table depth); forcing = NLDAS-2 (0.125°, ~12 km) precip at the column.</a:t>
             </a:r>
           </a:p>
         </p:txBody>
@@ -10564,7 +10564,7 @@
                   <a:srgbClr val="475569"/>
                 </a:solidFill>
               </a:rPr>
-              <a:t>Definitions — recharge = ELM QCHARGE (flux from the soil column to the water table); runoff = QOVER (surface runoff); recharge fraction = QCHARGE/(QCHARGE+QOVER); WTD = ZWT (the column's own water-table depth); forcing = CLM_QIAN (Qian 2006, T62 ≈ 1.9°) precip at the column.</a:t>
+              <a:t>Definitions — recharge = ELM QCHARGE (flux from the soil column to the water table); runoff = QOVER (surface runoff); recharge fraction = QCHARGE/(QCHARGE+QOVER); WTD = ZWT (the column's own water-table depth); forcing = NLDAS-2 (0.125°, ~12 km) precip at the column.</a:t>
             </a:r>
           </a:p>
         </p:txBody>
@@ -11671,7 +11671,7 @@
                   <a:srgbClr val="475569"/>
                 </a:solidFill>
               </a:rPr>
-              <a:t>characteristics from the real data (SSURGO soil, Fan 2013 WTD, Qian forcing) · results are annual means (mm/yr)</a:t>
+              <a:t>characteristics from the real data (SSURGO soil, Fan 2013 WTD, NLDAS-2 (0.125°, ~12 km) forcing) · results are annual means (mm/yr)</a:t>
             </a:r>
           </a:p>
         </p:txBody>
@@ -15307,7 +15307,7 @@
                   <a:srgbClr val="475569"/>
                 </a:solidFill>
               </a:rPr>
-              <a:t>characteristics from the real data (SSURGO soil, Fan 2013 WTD, Qian forcing) · results are annual means (mm/yr)</a:t>
+              <a:t>characteristics from the real data (SSURGO soil, Fan 2013 WTD, NLDAS-2 (0.125°, ~12 km) forcing) · results are annual means (mm/yr)</a:t>
             </a:r>
           </a:p>
         </p:txBody>
@@ -18943,7 +18943,7 @@
                   <a:srgbClr val="475569"/>
                 </a:solidFill>
               </a:rPr>
-              <a:t>characteristics from the real data (SSURGO soil, Fan 2013 WTD, Qian forcing) · results are annual means (mm/yr)</a:t>
+              <a:t>characteristics from the real data (SSURGO soil, Fan 2013 WTD, CLM_QIAN (Qian 2006, T62 ≈ 1.9°) forcing) · results are annual means (mm/yr)</a:t>
             </a:r>
           </a:p>
         </p:txBody>
@@ -20909,7 +20909,7 @@
                   <a:srgbClr val="475569"/>
                 </a:solidFill>
               </a:rPr>
-              <a:t>characteristics from the real data (SSURGO soil, Fan 2013 WTD, Qian forcing) · results are annual means (mm/yr)</a:t>
+              <a:t>characteristics from the real data (SSURGO soil, Fan 2013 WTD, CLM_QIAN (Qian 2006, T62 ≈ 1.9°) forcing) · results are annual means (mm/yr)</a:t>
             </a:r>
           </a:p>
         </p:txBody>
@@ -22541,7 +22541,7 @@
                   <a:srgbClr val="475569"/>
                 </a:solidFill>
               </a:rPr>
-              <a:t>characteristics from the real data (SSURGO soil, Fan 2013 WTD, Qian forcing) · results are annual means (mm/yr)</a:t>
+              <a:t>characteristics from the real data (SSURGO soil, Fan 2013 WTD, CLM_QIAN (Qian 2006, T62 ≈ 1.9°) forcing) · results are annual means (mm/yr)</a:t>
             </a:r>
           </a:p>
         </p:txBody>
@@ -24173,7 +24173,7 @@
                   <a:srgbClr val="475569"/>
                 </a:solidFill>
               </a:rPr>
-              <a:t>characteristics from the real data (SSURGO soil, Fan 2013 WTD, Qian forcing) · results are annual means (mm/yr)</a:t>
+              <a:t>characteristics from the real data (SSURGO soil, Fan 2013 WTD, CLM_QIAN (Qian 2006, T62 ≈ 1.9°) forcing) · results are annual means (mm/yr)</a:t>
             </a:r>
           </a:p>
         </p:txBody>

</xml_diff>